<commit_message>
Add Queue Language reporting period guidance
Co-authored-by: Aankitgupta <Aankitgupta@users.noreply.github.com>
</commit_message>
<xml_diff>
--- a/queue_language_kpi_client_call.pptx
+++ b/queue_language_kpi_client_call.pptx
@@ -3960,7 +3960,7 @@
                 </a:solidFill>
                 <a:latin typeface="Arial"/>
               </a:rPr>
-              <a:t>Use highest handled call language as the default mapping for non-Verizon KPI sources</a:t>
+              <a:t>Use highest handled call language during the same KPI reporting period</a:t>
             </a:r>
           </a:p>
         </p:txBody>
@@ -4845,7 +4845,7 @@
                 </a:solidFill>
                 <a:latin typeface="Arial"/>
               </a:rPr>
-              <a:t>Confirm refresh period, tie handling, and new-agent fallback before implementation.</a:t>
+              <a:t>Recommended period: count calls for the same KPI reporting period selected in the dashboard. If no period is selected, use the latest completed month. Also confirm tie handling and new-agent fallback.</a:t>
             </a:r>
           </a:p>
         </p:txBody>
@@ -4915,7 +4915,7 @@
                 </a:solidFill>
                 <a:latin typeface="Arial"/>
               </a:rPr>
-              <a:t>Proceed with the highest handled call language rule because it is easy to explain, auditable, and matches the client preference in the mail chain.</a:t>
+              <a:t>Proceed with the highest handled call language rule using the KPI reporting period, so language assignment reflects the same time window as the metrics being reviewed.</a:t>
             </a:r>
           </a:p>
         </p:txBody>

</xml_diff>